<commit_message>
LSA Meteorology: all lessons rewritten along the syllabus, one point per slide with 2-3 explaining sentences; L10 relevance shows importance only
Co-Authored-By: Claude Opus 5.5 <noreply@anthropic.com>
Claude-Session: https://claude.ai/code/session_0115LFSb2ktGLWPeVksFkSer
</commit_message>
<xml_diff>
--- a/lecons/LSA/Meteorology/03_LSA_MET_L03_Solar_Radiation.pptx
+++ b/lecons/LSA/Meteorology/03_LSA_MET_L03_Solar_Radiation.pptx
@@ -3198,7 +3198,7 @@
           <a:p>
             <a:r>
               <a:rPr lang="en-US" dirty="0"/>
-              <a:t>Let us copy Source and Nature of Solar Radiation. Solar radiation has the following source and nature. Copy the point on Source on the left, then draw the diagram on the right: the Sun. Give it a title and label it clearly.</a:t>
+              <a:t>Let us copy Source. Solar radiation has the following source. Copy the point on The Sun on the left, then draw the diagram on the right: the Sun. Give it a title and label it clearly.</a:t>
             </a:r>
             <a:endParaRPr lang="en-US" dirty="0"/>
           </a:p>
@@ -3286,7 +3286,7 @@
           <a:p>
             <a:r>
               <a:rPr lang="en-US" dirty="0"/>
-              <a:t>We continue with Source and Nature of Solar Radiation. On this slide we have Electromagnetic waves and Composition. Write each point on a new line, with the key term first, and explain it in your own words when we revise. When you finish, we go to the next slide.</a:t>
+              <a:t>We continue with Source. Copy the point on The solar constant: write the key term first, then its explanation.</a:t>
             </a:r>
             <a:endParaRPr lang="en-US" dirty="0"/>
           </a:p>
@@ -3374,7 +3374,7 @@
           <a:p>
             <a:r>
               <a:rPr lang="en-US" dirty="0"/>
-              <a:t>We continue with Source and Nature of Solar Radiation. Copy this carefully.</a:t>
+              <a:t>Let us copy Nature. Solar radiation is short-wave electromagnetic energy made of the following rays. Copy the point on Ultraviolet rays (about 9 %) on the left, then draw the diagram on the right: the solar spectrum. Give it a title and label it clearly.</a:t>
             </a:r>
             <a:endParaRPr lang="en-US" dirty="0"/>
           </a:p>
@@ -3550,7 +3550,7 @@
           <a:p>
             <a:r>
               <a:rPr lang="en-US" dirty="0"/>
-              <a:t>Copy the point on Illustration on the left, then draw the diagram on the right: the spectrum. Give it a title and label it clearly.</a:t>
+              <a:t>We continue with Nature. Copy the point on Visible light (about 40 %): write the key term first, then its explanation.</a:t>
             </a:r>
             <a:endParaRPr lang="en-US" dirty="0"/>
           </a:p>
@@ -3638,7 +3638,7 @@
           <a:p>
             <a:r>
               <a:rPr lang="en-US" dirty="0"/>
-              <a:t>Let us copy Depletion of Solar Radiation in the Atmosphere. Solar radiation is reduced in the atmosphere by the following processes. Copy the point on Overall budget on the left, then draw the diagram on the right: what happens to sunlight. Give it a title and label it clearly.</a:t>
+              <a:t>We continue with Nature. Copy the point on Infrared rays (about 51 %): write the key term first, then its explanation.</a:t>
             </a:r>
             <a:endParaRPr lang="en-US" dirty="0"/>
           </a:p>
@@ -3726,7 +3726,7 @@
           <a:p>
             <a:r>
               <a:rPr lang="en-US" dirty="0"/>
-              <a:t>Copy the point on Reflection on the left, then draw the diagram on the right: albedo of surfaces. Give it a title and label it clearly.</a:t>
+              <a:t>Let us copy Depletion of Solar Radiation. Solar radiation is reduced as it crosses the atmosphere by the following processes. Copy the point on Reflection on the left, then draw the diagram on the right: the albedo of surfaces. Give it a title and label it clearly.</a:t>
             </a:r>
             <a:endParaRPr lang="en-US" dirty="0"/>
           </a:p>
@@ -3814,7 +3814,7 @@
           <a:p>
             <a:r>
               <a:rPr lang="en-US" dirty="0"/>
-              <a:t>We continue with Depletion of Solar Radiation in the Atmosphere. On this slide we have Examples of albedo. Write each point on a new line, with the key term first, and explain it in your own words when we revise.</a:t>
+              <a:t>Copy the point on Scattering on the left, then draw the diagram on the right: a red sunrise. Give it a title and label it clearly.</a:t>
             </a:r>
             <a:endParaRPr lang="en-US" dirty="0"/>
           </a:p>
@@ -3902,7 +3902,7 @@
           <a:p>
             <a:r>
               <a:rPr lang="en-US" dirty="0"/>
-              <a:t>Copy the point on Scattering on the left, then draw the diagram on the right: a red sunrise. Give it a title and label it clearly.</a:t>
+              <a:t>We continue with Depletion of Solar Radiation. Copy the point on Absorption: write the key term first, then its explanation.</a:t>
             </a:r>
             <a:endParaRPr lang="en-US" dirty="0"/>
           </a:p>
@@ -3990,7 +3990,7 @@
           <a:p>
             <a:r>
               <a:rPr lang="en-US" dirty="0"/>
-              <a:t>We continue with Depletion of Solar Radiation in the Atmosphere. On this slide we have Absorption. Write each point on a new line, with the key term first, and explain it in your own words when we revise.</a:t>
+              <a:t>Copy the point on Energy reaching the surface on the left, then draw the diagram on the right: the depletion of solar radiation. Give it a title and label it clearly.</a:t>
             </a:r>
             <a:endParaRPr lang="en-US" dirty="0"/>
           </a:p>
@@ -14578,8 +14578,49 @@
         </p:nvSpPr>
         <p:spPr>
           <a:xfrm>
-            <a:off x="365760" y="1783080"/>
-            <a:ext cx="4846320" cy="4617720"/>
+            <a:off x="365760" y="1737360"/>
+            <a:ext cx="6035040" cy="457200"/>
+          </a:xfrm>
+          <a:prstGeom prst="rect">
+            <a:avLst/>
+          </a:prstGeom>
+          <a:noFill/>
+          <a:ln/>
+        </p:spPr>
+        <p:txBody>
+          <a:bodyPr wrap="square" lIns="0" tIns="0" rIns="0" bIns="0" rtlCol="0" anchor="ctr">
+            <a:normAutofit/>
+          </a:bodyPr>
+          <a:lstStyle/>
+          <a:p>
+            <a:pPr algn="l" indent="0" marL="0">
+              <a:buNone/>
+            </a:pPr>
+            <a:r>
+              <a:rPr lang="en-US" sz="3000" b="1" dirty="0">
+                <a:solidFill>
+                  <a:srgbClr val="990011"/>
+                </a:solidFill>
+                <a:latin typeface="Times New Roman" pitchFamily="34" charset="0"/>
+                <a:ea typeface="Times New Roman" pitchFamily="34" charset="-122"/>
+                <a:cs typeface="Times New Roman" pitchFamily="34" charset="-120"/>
+              </a:rPr>
+              <a:t>A) Source</a:t>
+            </a:r>
+            <a:endParaRPr lang="en-US" sz="3000" dirty="0"/>
+          </a:p>
+        </p:txBody>
+      </p:sp>
+      <p:sp>
+        <p:nvSpPr>
+          <p:cNvPr id="5" name="Text 3"/>
+          <p:cNvSpPr/>
+          <p:nvPr/>
+        </p:nvSpPr>
+        <p:spPr>
+          <a:xfrm>
+            <a:off x="365760" y="2240280"/>
+            <a:ext cx="6035040" cy="4160520"/>
           </a:xfrm>
           <a:prstGeom prst="rect">
             <a:avLst/>
@@ -14598,7 +14639,7 @@
               <a:buNone/>
             </a:pPr>
             <a:r>
-              <a:rPr lang="en-US" sz="3600" i="1" dirty="0">
+              <a:rPr lang="en-US" sz="2800" i="1" dirty="0">
                 <a:solidFill>
                   <a:srgbClr val="111111"/>
                 </a:solidFill>
@@ -14606,9 +14647,9 @@
                 <a:ea typeface="Times New Roman" pitchFamily="34" charset="-122"/>
                 <a:cs typeface="Times New Roman" pitchFamily="34" charset="-120"/>
               </a:rPr>
-              <a:t>Solar radiation has the following source and nature:</a:t>
-            </a:r>
-            <a:endParaRPr lang="en-US" sz="3600" dirty="0"/>
+              <a:t>Solar radiation has the following source:</a:t>
+            </a:r>
+            <a:endParaRPr lang="en-US" sz="2800" dirty="0"/>
           </a:p>
           <a:p>
             <a:pPr algn="l" indent="0" marL="0">
@@ -14618,7 +14659,7 @@
               <a:buNone/>
             </a:pPr>
             <a:r>
-              <a:rPr lang="en-US" sz="3600" b="1" dirty="0">
+              <a:rPr lang="en-US" sz="2800" b="1" dirty="0">
                 <a:solidFill>
                   <a:srgbClr val="111111"/>
                 </a:solidFill>
@@ -14626,7 +14667,7 @@
                 <a:ea typeface="Times New Roman" pitchFamily="34" charset="-122"/>
                 <a:cs typeface="Times New Roman" pitchFamily="34" charset="-120"/>
               </a:rPr>
-              <a:t>Source: </a:t>
+              <a:t>The Sun: </a:t>
             </a:r>
             <a:pPr algn="l" indent="0" marL="0">
               <a:spcAft>
@@ -14635,7 +14676,7 @@
               <a:buNone/>
             </a:pPr>
             <a:r>
-              <a:rPr lang="en-US" sz="3600" dirty="0">
+              <a:rPr lang="en-US" sz="2800" dirty="0">
                 <a:solidFill>
                   <a:srgbClr val="111111"/>
                 </a:solidFill>
@@ -14643,15 +14684,15 @@
                 <a:ea typeface="Times New Roman" pitchFamily="34" charset="-122"/>
                 <a:cs typeface="Times New Roman" pitchFamily="34" charset="-120"/>
               </a:rPr>
-              <a:t>The Sun produces energy by nuclear fusion at a surface temperature of about 5,500 °C.</a:t>
-            </a:r>
-            <a:endParaRPr lang="en-US" sz="3600" dirty="0"/>
+              <a:t>The Sun produces energy by nuclear fusion, in which hydrogen changes into helium, and its surface is at about 5,500 °C. This energy travels through space at the speed of light and reaches the Earth in about 8 minutes.</a:t>
+            </a:r>
+            <a:endParaRPr lang="en-US" sz="2800" dirty="0"/>
           </a:p>
         </p:txBody>
       </p:sp>
       <p:pic>
         <p:nvPicPr>
-          <p:cNvPr id="5" name="Image 0" descr="/home/claude/f4/img/v2/lsa_sun.jpg">    </p:cNvPr>
+          <p:cNvPr id="6" name="Image 0" descr="/home/claude/f4/img/v2/lsa_sun.jpg">    </p:cNvPr>
           <p:cNvPicPr>
             <a:picLocks noChangeAspect="1"/>
           </p:cNvPicPr>
@@ -14665,8 +14706,8 @@
         </p:blipFill>
         <p:spPr>
           <a:xfrm>
-            <a:off x="5349240" y="2071212"/>
-            <a:ext cx="6659575" cy="3693983"/>
+            <a:off x="6537960" y="2400897"/>
+            <a:ext cx="5470855" cy="3034615"/>
           </a:xfrm>
           <a:prstGeom prst="rect">
             <a:avLst/>
@@ -14675,14 +14716,14 @@
       </p:pic>
       <p:sp>
         <p:nvSpPr>
-          <p:cNvPr id="6" name="Text 3"/>
+          <p:cNvPr id="7" name="Text 4"/>
           <p:cNvSpPr/>
           <p:nvPr/>
         </p:nvSpPr>
         <p:spPr>
           <a:xfrm>
-            <a:off x="5349240" y="6089904"/>
-            <a:ext cx="6659575" cy="347472"/>
+            <a:off x="6537960" y="6089904"/>
+            <a:ext cx="5470855" cy="347472"/>
           </a:xfrm>
           <a:prstGeom prst="rect">
             <a:avLst/>
@@ -14841,7 +14882,7 @@
         <p:spPr>
           <a:xfrm>
             <a:off x="0" y="658368"/>
-            <a:ext cx="3840480" cy="5833872"/>
+            <a:ext cx="2468880" cy="5833872"/>
           </a:xfrm>
           <a:prstGeom prst="rect">
             <a:avLst/>
@@ -14856,8 +14897,8 @@
         </p:nvSpPr>
         <p:spPr>
           <a:xfrm>
-            <a:off x="4069080" y="1005840"/>
-            <a:ext cx="7802575" cy="731520"/>
+            <a:off x="2697480" y="1005840"/>
+            <a:ext cx="9174175" cy="731520"/>
           </a:xfrm>
           <a:prstGeom prst="rect">
             <a:avLst/>
@@ -14897,8 +14938,47 @@
         </p:nvSpPr>
         <p:spPr>
           <a:xfrm>
-            <a:off x="4069080" y="1783080"/>
-            <a:ext cx="7802575" cy="4663440"/>
+            <a:off x="2697480" y="1737360"/>
+            <a:ext cx="9174175" cy="457200"/>
+          </a:xfrm>
+          <a:prstGeom prst="rect">
+            <a:avLst/>
+          </a:prstGeom>
+          <a:noFill/>
+          <a:ln/>
+        </p:spPr>
+        <p:txBody>
+          <a:bodyPr wrap="square" lIns="0" tIns="0" rIns="0" bIns="0" rtlCol="0" anchor="ctr"/>
+          <a:lstStyle/>
+          <a:p>
+            <a:pPr algn="l" indent="0" marL="0">
+              <a:buNone/>
+            </a:pPr>
+            <a:r>
+              <a:rPr lang="en-US" sz="3200" b="1" dirty="0">
+                <a:solidFill>
+                  <a:srgbClr val="990011"/>
+                </a:solidFill>
+                <a:latin typeface="Times New Roman" pitchFamily="34" charset="0"/>
+                <a:ea typeface="Times New Roman" pitchFamily="34" charset="-122"/>
+                <a:cs typeface="Times New Roman" pitchFamily="34" charset="-120"/>
+              </a:rPr>
+              <a:t>A) Source</a:t>
+            </a:r>
+            <a:endParaRPr lang="en-US" sz="3200" dirty="0"/>
+          </a:p>
+        </p:txBody>
+      </p:sp>
+      <p:sp>
+        <p:nvSpPr>
+          <p:cNvPr id="6" name="Text 3"/>
+          <p:cNvSpPr/>
+          <p:nvPr/>
+        </p:nvSpPr>
+        <p:spPr>
+          <a:xfrm>
+            <a:off x="2697480" y="2240280"/>
+            <a:ext cx="9174175" cy="4206240"/>
           </a:xfrm>
           <a:prstGeom prst="rect">
             <a:avLst/>
@@ -14925,7 +15005,7 @@
                 <a:ea typeface="Times New Roman" pitchFamily="34" charset="-122"/>
                 <a:cs typeface="Times New Roman" pitchFamily="34" charset="-120"/>
               </a:rPr>
-              <a:t>Electromagnetic waves: </a:t>
+              <a:t>The solar constant: </a:t>
             </a:r>
             <a:pPr algn="l" indent="0" marL="0">
               <a:spcAft>
@@ -14942,48 +15022,7 @@
                 <a:ea typeface="Times New Roman" pitchFamily="34" charset="-122"/>
                 <a:cs typeface="Times New Roman" pitchFamily="34" charset="-120"/>
               </a:rPr>
-              <a:t>The energy travels through space as waves at the speed of light.</a:t>
-            </a:r>
-            <a:endParaRPr lang="en-US" sz="4000" dirty="0"/>
-          </a:p>
-          <a:p>
-            <a:pPr algn="l" indent="0" marL="0">
-              <a:spcAft>
-                <a:spcPts val="800"/>
-              </a:spcAft>
-              <a:buNone/>
-            </a:pPr>
-            <a:r>
-              <a:rPr lang="en-US" sz="4000" b="1" dirty="0">
-                <a:solidFill>
-                  <a:srgbClr val="111111"/>
-                </a:solidFill>
-                <a:latin typeface="Times New Roman" pitchFamily="34" charset="0"/>
-                <a:ea typeface="Times New Roman" pitchFamily="34" charset="-122"/>
-                <a:cs typeface="Times New Roman" pitchFamily="34" charset="-120"/>
-              </a:rPr>
-              <a:t>Composition:</a:t>
-            </a:r>
-            <a:endParaRPr lang="en-US" sz="4000" dirty="0"/>
-          </a:p>
-          <a:p>
-            <a:pPr algn="l" marL="342900" indent="-342900">
-              <a:spcAft>
-                <a:spcPts val="800"/>
-              </a:spcAft>
-              <a:buSzPct val="100000"/>
-              <a:buChar char="•"/>
-            </a:pPr>
-            <a:r>
-              <a:rPr lang="en-US" sz="4000" dirty="0">
-                <a:solidFill>
-                  <a:srgbClr val="111111"/>
-                </a:solidFill>
-                <a:latin typeface="Times New Roman" pitchFamily="34" charset="0"/>
-                <a:ea typeface="Times New Roman" pitchFamily="34" charset="-122"/>
-                <a:cs typeface="Times New Roman" pitchFamily="34" charset="-120"/>
-              </a:rPr>
-              <a:t>Ultraviolet: short, invisible waves that burn the skin.</a:t>
+              <a:t>At the top of the atmosphere, each square metre facing the Sun receives about 1,361 watts. The Earth receives only a tiny part of the energy of the Sun, but it is enough to drive all weather.</a:t>
             </a:r>
             <a:endParaRPr lang="en-US" sz="4000" dirty="0"/>
           </a:p>
@@ -15101,9 +15140,170 @@
           </a:p>
         </p:txBody>
       </p:sp>
+      <p:sp>
+        <p:nvSpPr>
+          <p:cNvPr id="3" name="Text 1"/>
+          <p:cNvSpPr/>
+          <p:nvPr/>
+        </p:nvSpPr>
+        <p:spPr>
+          <a:xfrm>
+            <a:off x="365760" y="1005840"/>
+            <a:ext cx="11460175" cy="731520"/>
+          </a:xfrm>
+          <a:prstGeom prst="rect">
+            <a:avLst/>
+          </a:prstGeom>
+          <a:noFill/>
+          <a:ln/>
+        </p:spPr>
+        <p:txBody>
+          <a:bodyPr wrap="square" lIns="0" tIns="0" rIns="0" bIns="0" rtlCol="0" anchor="ctr">
+            <a:normAutofit/>
+          </a:bodyPr>
+          <a:lstStyle/>
+          <a:p>
+            <a:pPr algn="ctr" indent="0" marL="0">
+              <a:buNone/>
+            </a:pPr>
+            <a:r>
+              <a:rPr lang="en-US" sz="3600" b="1" dirty="0">
+                <a:solidFill>
+                  <a:srgbClr val="990011"/>
+                </a:solidFill>
+                <a:latin typeface="Times New Roman" pitchFamily="34" charset="0"/>
+                <a:ea typeface="Times New Roman" pitchFamily="34" charset="-122"/>
+                <a:cs typeface="Times New Roman" pitchFamily="34" charset="-120"/>
+              </a:rPr>
+              <a:t>1. Source and Nature of Solar Radiation</a:t>
+            </a:r>
+            <a:endParaRPr lang="en-US" sz="3600" dirty="0"/>
+          </a:p>
+        </p:txBody>
+      </p:sp>
+      <p:sp>
+        <p:nvSpPr>
+          <p:cNvPr id="4" name="Text 2"/>
+          <p:cNvSpPr/>
+          <p:nvPr/>
+        </p:nvSpPr>
+        <p:spPr>
+          <a:xfrm>
+            <a:off x="365760" y="1737360"/>
+            <a:ext cx="6035040" cy="457200"/>
+          </a:xfrm>
+          <a:prstGeom prst="rect">
+            <a:avLst/>
+          </a:prstGeom>
+          <a:noFill/>
+          <a:ln/>
+        </p:spPr>
+        <p:txBody>
+          <a:bodyPr wrap="square" lIns="0" tIns="0" rIns="0" bIns="0" rtlCol="0" anchor="ctr">
+            <a:normAutofit/>
+          </a:bodyPr>
+          <a:lstStyle/>
+          <a:p>
+            <a:pPr algn="l" indent="0" marL="0">
+              <a:buNone/>
+            </a:pPr>
+            <a:r>
+              <a:rPr lang="en-US" sz="3000" b="1" dirty="0">
+                <a:solidFill>
+                  <a:srgbClr val="990011"/>
+                </a:solidFill>
+                <a:latin typeface="Times New Roman" pitchFamily="34" charset="0"/>
+                <a:ea typeface="Times New Roman" pitchFamily="34" charset="-122"/>
+                <a:cs typeface="Times New Roman" pitchFamily="34" charset="-120"/>
+              </a:rPr>
+              <a:t>B) Nature</a:t>
+            </a:r>
+            <a:endParaRPr lang="en-US" sz="3000" dirty="0"/>
+          </a:p>
+        </p:txBody>
+      </p:sp>
+      <p:sp>
+        <p:nvSpPr>
+          <p:cNvPr id="5" name="Text 3"/>
+          <p:cNvSpPr/>
+          <p:nvPr/>
+        </p:nvSpPr>
+        <p:spPr>
+          <a:xfrm>
+            <a:off x="365760" y="2240280"/>
+            <a:ext cx="6035040" cy="4160520"/>
+          </a:xfrm>
+          <a:prstGeom prst="rect">
+            <a:avLst/>
+          </a:prstGeom>
+          <a:noFill/>
+          <a:ln/>
+        </p:spPr>
+        <p:txBody>
+          <a:bodyPr wrap="square" lIns="0" tIns="0" rIns="0" bIns="0" rtlCol="0" anchor="t"/>
+          <a:lstStyle/>
+          <a:p>
+            <a:pPr algn="l" indent="0" marL="0">
+              <a:spcAft>
+                <a:spcPts val="800"/>
+              </a:spcAft>
+              <a:buNone/>
+            </a:pPr>
+            <a:r>
+              <a:rPr lang="en-US" sz="3000" i="1" dirty="0">
+                <a:solidFill>
+                  <a:srgbClr val="111111"/>
+                </a:solidFill>
+                <a:latin typeface="Times New Roman" pitchFamily="34" charset="0"/>
+                <a:ea typeface="Times New Roman" pitchFamily="34" charset="-122"/>
+                <a:cs typeface="Times New Roman" pitchFamily="34" charset="-120"/>
+              </a:rPr>
+              <a:t>Solar radiation is short-wave electromagnetic energy made of the following rays:</a:t>
+            </a:r>
+            <a:endParaRPr lang="en-US" sz="3000" dirty="0"/>
+          </a:p>
+          <a:p>
+            <a:pPr algn="l" indent="0" marL="0">
+              <a:spcAft>
+                <a:spcPts val="800"/>
+              </a:spcAft>
+              <a:buNone/>
+            </a:pPr>
+            <a:r>
+              <a:rPr lang="en-US" sz="3000" b="1" dirty="0">
+                <a:solidFill>
+                  <a:srgbClr val="111111"/>
+                </a:solidFill>
+                <a:latin typeface="Times New Roman" pitchFamily="34" charset="0"/>
+                <a:ea typeface="Times New Roman" pitchFamily="34" charset="-122"/>
+                <a:cs typeface="Times New Roman" pitchFamily="34" charset="-120"/>
+              </a:rPr>
+              <a:t>Ultraviolet rays (about 9 %): </a:t>
+            </a:r>
+            <a:pPr algn="l" indent="0" marL="0">
+              <a:spcAft>
+                <a:spcPts val="800"/>
+              </a:spcAft>
+              <a:buNone/>
+            </a:pPr>
+            <a:r>
+              <a:rPr lang="en-US" sz="3000" dirty="0">
+                <a:solidFill>
+                  <a:srgbClr val="111111"/>
+                </a:solidFill>
+                <a:latin typeface="Times New Roman" pitchFamily="34" charset="0"/>
+                <a:ea typeface="Times New Roman" pitchFamily="34" charset="-122"/>
+                <a:cs typeface="Times New Roman" pitchFamily="34" charset="-120"/>
+              </a:rPr>
+              <a:t>They are short, invisible waves with much energy. Most are absorbed by the ozone layer, and those that reach the ground burn the skin.</a:t>
+            </a:r>
+            <a:endParaRPr lang="en-US" sz="3000" dirty="0"/>
+          </a:p>
+        </p:txBody>
+      </p:sp>
       <p:pic>
         <p:nvPicPr>
-          <p:cNvPr id="3" name="Image 0" descr="/home/claude/f4/img/minesec_sheet.png">    </p:cNvPr>
+          <p:cNvPr id="6" name="Image 0" descr="/home/claude/f4/img/v2/spectrum_big.png">    </p:cNvPr>
           <p:cNvPicPr>
             <a:picLocks noChangeAspect="1"/>
           </p:cNvPicPr>
@@ -15117,8 +15317,8 @@
         </p:blipFill>
         <p:spPr>
           <a:xfrm>
-            <a:off x="0" y="658368"/>
-            <a:ext cx="5120640" cy="5833872"/>
+            <a:off x="6537960" y="2849678"/>
+            <a:ext cx="5470855" cy="2137053"/>
           </a:xfrm>
           <a:prstGeom prst="rect">
             <a:avLst/>
@@ -15127,14 +15327,14 @@
       </p:pic>
       <p:sp>
         <p:nvSpPr>
-          <p:cNvPr id="4" name="Text 1"/>
+          <p:cNvPr id="7" name="Text 4"/>
           <p:cNvSpPr/>
           <p:nvPr/>
         </p:nvSpPr>
         <p:spPr>
           <a:xfrm>
-            <a:off x="5349240" y="1005840"/>
-            <a:ext cx="6522415" cy="731520"/>
+            <a:off x="6537960" y="6089904"/>
+            <a:ext cx="5470855" cy="347472"/>
           </a:xfrm>
           <a:prstGeom prst="rect">
             <a:avLst/>
@@ -15143,90 +15343,24 @@
           <a:ln/>
         </p:spPr>
         <p:txBody>
-          <a:bodyPr wrap="square" lIns="0" tIns="0" rIns="0" bIns="0" rtlCol="0" anchor="ctr">
-            <a:normAutofit/>
-          </a:bodyPr>
+          <a:bodyPr wrap="square" lIns="0" tIns="0" rIns="0" bIns="0" rtlCol="0" anchor="ctr"/>
           <a:lstStyle/>
           <a:p>
             <a:pPr algn="ctr" indent="0" marL="0">
               <a:buNone/>
             </a:pPr>
             <a:r>
-              <a:rPr lang="en-US" sz="3600" b="1" dirty="0">
-                <a:solidFill>
-                  <a:srgbClr val="990011"/>
+              <a:rPr lang="en-US" sz="1600" i="1" dirty="0">
+                <a:solidFill>
+                  <a:srgbClr val="555555"/>
                 </a:solidFill>
                 <a:latin typeface="Times New Roman" pitchFamily="34" charset="0"/>
                 <a:ea typeface="Times New Roman" pitchFamily="34" charset="-122"/>
                 <a:cs typeface="Times New Roman" pitchFamily="34" charset="-120"/>
               </a:rPr>
-              <a:t>1. Source and Nature of Solar Radiation (continued)</a:t>
-            </a:r>
-            <a:endParaRPr lang="en-US" sz="3600" dirty="0"/>
-          </a:p>
-        </p:txBody>
-      </p:sp>
-      <p:sp>
-        <p:nvSpPr>
-          <p:cNvPr id="5" name="Text 2"/>
-          <p:cNvSpPr/>
-          <p:nvPr/>
-        </p:nvSpPr>
-        <p:spPr>
-          <a:xfrm>
-            <a:off x="5349240" y="1783080"/>
-            <a:ext cx="6522415" cy="4663440"/>
-          </a:xfrm>
-          <a:prstGeom prst="rect">
-            <a:avLst/>
-          </a:prstGeom>
-          <a:noFill/>
-          <a:ln/>
-        </p:spPr>
-        <p:txBody>
-          <a:bodyPr wrap="square" lIns="0" tIns="0" rIns="0" bIns="0" rtlCol="0" anchor="t"/>
-          <a:lstStyle/>
-          <a:p>
-            <a:pPr algn="l" marL="342900" indent="-342900">
-              <a:spcAft>
-                <a:spcPts val="800"/>
-              </a:spcAft>
-              <a:buSzPct val="100000"/>
-              <a:buChar char="•"/>
-            </a:pPr>
-            <a:r>
-              <a:rPr lang="en-US" sz="4000" dirty="0">
-                <a:solidFill>
-                  <a:srgbClr val="111111"/>
-                </a:solidFill>
-                <a:latin typeface="Times New Roman" pitchFamily="34" charset="0"/>
-                <a:ea typeface="Times New Roman" pitchFamily="34" charset="-122"/>
-                <a:cs typeface="Times New Roman" pitchFamily="34" charset="-120"/>
-              </a:rPr>
-              <a:t>Visible light: the colours we see.</a:t>
-            </a:r>
-            <a:endParaRPr lang="en-US" sz="4000" dirty="0"/>
-          </a:p>
-          <a:p>
-            <a:pPr algn="l" marL="342900" indent="-342900">
-              <a:spcAft>
-                <a:spcPts val="800"/>
-              </a:spcAft>
-              <a:buSzPct val="100000"/>
-              <a:buChar char="•"/>
-            </a:pPr>
-            <a:r>
-              <a:rPr lang="en-US" sz="4000" dirty="0">
-                <a:solidFill>
-                  <a:srgbClr val="111111"/>
-                </a:solidFill>
-                <a:latin typeface="Times New Roman" pitchFamily="34" charset="0"/>
-                <a:ea typeface="Times New Roman" pitchFamily="34" charset="-122"/>
-                <a:cs typeface="Times New Roman" pitchFamily="34" charset="-120"/>
-              </a:rPr>
-              <a:t>Infrared: long, invisible waves felt as heat.</a:t>
-            </a:r>
-            <a:endParaRPr lang="en-US" sz="4000" dirty="0"/>
+              <a:t>Illustration: the solar spectrum</a:t>
+            </a:r>
+            <a:endParaRPr lang="en-US" sz="1600" dirty="0"/>
           </a:p>
         </p:txBody>
       </p:sp>
@@ -15581,109 +15715,9 @@
           </a:p>
         </p:txBody>
       </p:sp>
-      <p:sp>
-        <p:nvSpPr>
-          <p:cNvPr id="3" name="Text 1"/>
-          <p:cNvSpPr/>
-          <p:nvPr/>
-        </p:nvSpPr>
-        <p:spPr>
-          <a:xfrm>
-            <a:off x="365760" y="1005840"/>
-            <a:ext cx="11460175" cy="731520"/>
-          </a:xfrm>
-          <a:prstGeom prst="rect">
-            <a:avLst/>
-          </a:prstGeom>
-          <a:noFill/>
-          <a:ln/>
-        </p:spPr>
-        <p:txBody>
-          <a:bodyPr wrap="square" lIns="0" tIns="0" rIns="0" bIns="0" rtlCol="0" anchor="ctr">
-            <a:normAutofit/>
-          </a:bodyPr>
-          <a:lstStyle/>
-          <a:p>
-            <a:pPr algn="ctr" indent="0" marL="0">
-              <a:buNone/>
-            </a:pPr>
-            <a:r>
-              <a:rPr lang="en-US" sz="3600" b="1" dirty="0">
-                <a:solidFill>
-                  <a:srgbClr val="990011"/>
-                </a:solidFill>
-                <a:latin typeface="Times New Roman" pitchFamily="34" charset="0"/>
-                <a:ea typeface="Times New Roman" pitchFamily="34" charset="-122"/>
-                <a:cs typeface="Times New Roman" pitchFamily="34" charset="-120"/>
-              </a:rPr>
-              <a:t>1. Source and Nature of Solar Radiation</a:t>
-            </a:r>
-            <a:endParaRPr lang="en-US" sz="3600" dirty="0"/>
-          </a:p>
-        </p:txBody>
-      </p:sp>
-      <p:sp>
-        <p:nvSpPr>
-          <p:cNvPr id="4" name="Text 2"/>
-          <p:cNvSpPr/>
-          <p:nvPr/>
-        </p:nvSpPr>
-        <p:spPr>
-          <a:xfrm>
-            <a:off x="365760" y="1783080"/>
-            <a:ext cx="4846320" cy="4617720"/>
-          </a:xfrm>
-          <a:prstGeom prst="rect">
-            <a:avLst/>
-          </a:prstGeom>
-          <a:noFill/>
-          <a:ln/>
-        </p:spPr>
-        <p:txBody>
-          <a:bodyPr wrap="square" lIns="0" tIns="0" rIns="0" bIns="0" rtlCol="0" anchor="t"/>
-          <a:lstStyle/>
-          <a:p>
-            <a:pPr algn="l" indent="0" marL="0">
-              <a:spcAft>
-                <a:spcPts val="800"/>
-              </a:spcAft>
-              <a:buNone/>
-            </a:pPr>
-            <a:r>
-              <a:rPr lang="en-US" sz="3600" b="1" dirty="0">
-                <a:solidFill>
-                  <a:srgbClr val="111111"/>
-                </a:solidFill>
-                <a:latin typeface="Times New Roman" pitchFamily="34" charset="0"/>
-                <a:ea typeface="Times New Roman" pitchFamily="34" charset="-122"/>
-                <a:cs typeface="Times New Roman" pitchFamily="34" charset="-120"/>
-              </a:rPr>
-              <a:t>Illustration: </a:t>
-            </a:r>
-            <a:pPr algn="l" indent="0" marL="0">
-              <a:spcAft>
-                <a:spcPts val="800"/>
-              </a:spcAft>
-              <a:buNone/>
-            </a:pPr>
-            <a:r>
-              <a:rPr lang="en-US" sz="3600" dirty="0">
-                <a:solidFill>
-                  <a:srgbClr val="111111"/>
-                </a:solidFill>
-                <a:latin typeface="Times New Roman" pitchFamily="34" charset="0"/>
-                <a:ea typeface="Times New Roman" pitchFamily="34" charset="-122"/>
-                <a:cs typeface="Times New Roman" pitchFamily="34" charset="-120"/>
-              </a:rPr>
-              <a:t>Most solar energy arrives as visible light and near infrared.</a:t>
-            </a:r>
-            <a:endParaRPr lang="en-US" sz="3600" dirty="0"/>
-          </a:p>
-        </p:txBody>
-      </p:sp>
       <p:pic>
         <p:nvPicPr>
-          <p:cNvPr id="5" name="Image 0" descr="/home/claude/f4/img/v2/spectrum_big.png">    </p:cNvPr>
+          <p:cNvPr id="3" name="Image 0" descr="/home/claude/f4/img/minesec_sheet.png">    </p:cNvPr>
           <p:cNvPicPr>
             <a:picLocks noChangeAspect="1"/>
           </p:cNvPicPr>
@@ -15697,8 +15731,8 @@
         </p:blipFill>
         <p:spPr>
           <a:xfrm>
-            <a:off x="5349240" y="2617506"/>
-            <a:ext cx="6659575" cy="2601397"/>
+            <a:off x="0" y="658368"/>
+            <a:ext cx="3840480" cy="5833872"/>
           </a:xfrm>
           <a:prstGeom prst="rect">
             <a:avLst/>
@@ -15707,14 +15741,14 @@
       </p:pic>
       <p:sp>
         <p:nvSpPr>
-          <p:cNvPr id="6" name="Text 3"/>
+          <p:cNvPr id="4" name="Text 1"/>
           <p:cNvSpPr/>
           <p:nvPr/>
         </p:nvSpPr>
         <p:spPr>
           <a:xfrm>
-            <a:off x="5349240" y="6089904"/>
-            <a:ext cx="6659575" cy="347472"/>
+            <a:off x="4069080" y="1005840"/>
+            <a:ext cx="7802575" cy="731520"/>
           </a:xfrm>
           <a:prstGeom prst="rect">
             <a:avLst/>
@@ -15723,24 +15757,124 @@
           <a:ln/>
         </p:spPr>
         <p:txBody>
-          <a:bodyPr wrap="square" lIns="0" tIns="0" rIns="0" bIns="0" rtlCol="0" anchor="ctr"/>
+          <a:bodyPr wrap="square" lIns="0" tIns="0" rIns="0" bIns="0" rtlCol="0" anchor="ctr">
+            <a:normAutofit/>
+          </a:bodyPr>
           <a:lstStyle/>
           <a:p>
             <a:pPr algn="ctr" indent="0" marL="0">
               <a:buNone/>
             </a:pPr>
             <a:r>
-              <a:rPr lang="en-US" sz="1600" i="1" dirty="0">
-                <a:solidFill>
-                  <a:srgbClr val="555555"/>
+              <a:rPr lang="en-US" sz="3600" b="1" dirty="0">
+                <a:solidFill>
+                  <a:srgbClr val="990011"/>
                 </a:solidFill>
                 <a:latin typeface="Times New Roman" pitchFamily="34" charset="0"/>
                 <a:ea typeface="Times New Roman" pitchFamily="34" charset="-122"/>
                 <a:cs typeface="Times New Roman" pitchFamily="34" charset="-120"/>
               </a:rPr>
-              <a:t>Illustration: the spectrum</a:t>
-            </a:r>
-            <a:endParaRPr lang="en-US" sz="1600" dirty="0"/>
+              <a:t>1. Source and Nature of Solar Radiation</a:t>
+            </a:r>
+            <a:endParaRPr lang="en-US" sz="3600" dirty="0"/>
+          </a:p>
+        </p:txBody>
+      </p:sp>
+      <p:sp>
+        <p:nvSpPr>
+          <p:cNvPr id="5" name="Text 2"/>
+          <p:cNvSpPr/>
+          <p:nvPr/>
+        </p:nvSpPr>
+        <p:spPr>
+          <a:xfrm>
+            <a:off x="4069080" y="1737360"/>
+            <a:ext cx="7802575" cy="457200"/>
+          </a:xfrm>
+          <a:prstGeom prst="rect">
+            <a:avLst/>
+          </a:prstGeom>
+          <a:noFill/>
+          <a:ln/>
+        </p:spPr>
+        <p:txBody>
+          <a:bodyPr wrap="square" lIns="0" tIns="0" rIns="0" bIns="0" rtlCol="0" anchor="ctr"/>
+          <a:lstStyle/>
+          <a:p>
+            <a:pPr algn="l" indent="0" marL="0">
+              <a:buNone/>
+            </a:pPr>
+            <a:r>
+              <a:rPr lang="en-US" sz="3200" b="1" dirty="0">
+                <a:solidFill>
+                  <a:srgbClr val="990011"/>
+                </a:solidFill>
+                <a:latin typeface="Times New Roman" pitchFamily="34" charset="0"/>
+                <a:ea typeface="Times New Roman" pitchFamily="34" charset="-122"/>
+                <a:cs typeface="Times New Roman" pitchFamily="34" charset="-120"/>
+              </a:rPr>
+              <a:t>B) Nature</a:t>
+            </a:r>
+            <a:endParaRPr lang="en-US" sz="3200" dirty="0"/>
+          </a:p>
+        </p:txBody>
+      </p:sp>
+      <p:sp>
+        <p:nvSpPr>
+          <p:cNvPr id="6" name="Text 3"/>
+          <p:cNvSpPr/>
+          <p:nvPr/>
+        </p:nvSpPr>
+        <p:spPr>
+          <a:xfrm>
+            <a:off x="4069080" y="2240280"/>
+            <a:ext cx="7802575" cy="4206240"/>
+          </a:xfrm>
+          <a:prstGeom prst="rect">
+            <a:avLst/>
+          </a:prstGeom>
+          <a:noFill/>
+          <a:ln/>
+        </p:spPr>
+        <p:txBody>
+          <a:bodyPr wrap="square" lIns="0" tIns="0" rIns="0" bIns="0" rtlCol="0" anchor="t"/>
+          <a:lstStyle/>
+          <a:p>
+            <a:pPr algn="l" indent="0" marL="0">
+              <a:spcAft>
+                <a:spcPts val="800"/>
+              </a:spcAft>
+              <a:buNone/>
+            </a:pPr>
+            <a:r>
+              <a:rPr lang="en-US" sz="4000" b="1" dirty="0">
+                <a:solidFill>
+                  <a:srgbClr val="111111"/>
+                </a:solidFill>
+                <a:latin typeface="Times New Roman" pitchFamily="34" charset="0"/>
+                <a:ea typeface="Times New Roman" pitchFamily="34" charset="-122"/>
+                <a:cs typeface="Times New Roman" pitchFamily="34" charset="-120"/>
+              </a:rPr>
+              <a:t>Visible light (about 40 %): </a:t>
+            </a:r>
+            <a:pPr algn="l" indent="0" marL="0">
+              <a:spcAft>
+                <a:spcPts val="800"/>
+              </a:spcAft>
+              <a:buNone/>
+            </a:pPr>
+            <a:r>
+              <a:rPr lang="en-US" sz="4000" dirty="0">
+                <a:solidFill>
+                  <a:srgbClr val="111111"/>
+                </a:solidFill>
+                <a:latin typeface="Times New Roman" pitchFamily="34" charset="0"/>
+                <a:ea typeface="Times New Roman" pitchFamily="34" charset="-122"/>
+                <a:cs typeface="Times New Roman" pitchFamily="34" charset="-120"/>
+              </a:rPr>
+              <a:t>It is the part of solar radiation that our eyes can see, made of the colours of the rainbow. It lights the Earth and is used by plants for photosynthesis.</a:t>
+            </a:r>
+            <a:endParaRPr lang="en-US" sz="4000" dirty="0"/>
           </a:p>
         </p:txBody>
       </p:sp>
@@ -15856,129 +15990,9 @@
           </a:p>
         </p:txBody>
       </p:sp>
-      <p:sp>
-        <p:nvSpPr>
-          <p:cNvPr id="3" name="Text 1"/>
-          <p:cNvSpPr/>
-          <p:nvPr/>
-        </p:nvSpPr>
-        <p:spPr>
-          <a:xfrm>
-            <a:off x="365760" y="1005840"/>
-            <a:ext cx="11460175" cy="731520"/>
-          </a:xfrm>
-          <a:prstGeom prst="rect">
-            <a:avLst/>
-          </a:prstGeom>
-          <a:noFill/>
-          <a:ln/>
-        </p:spPr>
-        <p:txBody>
-          <a:bodyPr wrap="square" lIns="0" tIns="0" rIns="0" bIns="0" rtlCol="0" anchor="ctr">
-            <a:normAutofit/>
-          </a:bodyPr>
-          <a:lstStyle/>
-          <a:p>
-            <a:pPr algn="ctr" indent="0" marL="0">
-              <a:buNone/>
-            </a:pPr>
-            <a:r>
-              <a:rPr lang="en-US" sz="3600" b="1" dirty="0">
-                <a:solidFill>
-                  <a:srgbClr val="990011"/>
-                </a:solidFill>
-                <a:latin typeface="Times New Roman" pitchFamily="34" charset="0"/>
-                <a:ea typeface="Times New Roman" pitchFamily="34" charset="-122"/>
-                <a:cs typeface="Times New Roman" pitchFamily="34" charset="-120"/>
-              </a:rPr>
-              <a:t>2. Depletion of Solar Radiation in the Atmosphere</a:t>
-            </a:r>
-            <a:endParaRPr lang="en-US" sz="3600" dirty="0"/>
-          </a:p>
-        </p:txBody>
-      </p:sp>
-      <p:sp>
-        <p:nvSpPr>
-          <p:cNvPr id="4" name="Text 2"/>
-          <p:cNvSpPr/>
-          <p:nvPr/>
-        </p:nvSpPr>
-        <p:spPr>
-          <a:xfrm>
-            <a:off x="365760" y="1783080"/>
-            <a:ext cx="4846320" cy="4617720"/>
-          </a:xfrm>
-          <a:prstGeom prst="rect">
-            <a:avLst/>
-          </a:prstGeom>
-          <a:noFill/>
-          <a:ln/>
-        </p:spPr>
-        <p:txBody>
-          <a:bodyPr wrap="square" lIns="0" tIns="0" rIns="0" bIns="0" rtlCol="0" anchor="t"/>
-          <a:lstStyle/>
-          <a:p>
-            <a:pPr algn="l" indent="0" marL="0">
-              <a:spcAft>
-                <a:spcPts val="800"/>
-              </a:spcAft>
-              <a:buNone/>
-            </a:pPr>
-            <a:r>
-              <a:rPr lang="en-US" sz="3200" i="1" dirty="0">
-                <a:solidFill>
-                  <a:srgbClr val="111111"/>
-                </a:solidFill>
-                <a:latin typeface="Times New Roman" pitchFamily="34" charset="0"/>
-                <a:ea typeface="Times New Roman" pitchFamily="34" charset="-122"/>
-                <a:cs typeface="Times New Roman" pitchFamily="34" charset="-120"/>
-              </a:rPr>
-              <a:t>Solar radiation is reduced in the atmosphere by the following processes:</a:t>
-            </a:r>
-            <a:endParaRPr lang="en-US" sz="3200" dirty="0"/>
-          </a:p>
-          <a:p>
-            <a:pPr algn="l" indent="0" marL="0">
-              <a:spcAft>
-                <a:spcPts val="800"/>
-              </a:spcAft>
-              <a:buNone/>
-            </a:pPr>
-            <a:r>
-              <a:rPr lang="en-US" sz="3200" b="1" dirty="0">
-                <a:solidFill>
-                  <a:srgbClr val="111111"/>
-                </a:solidFill>
-                <a:latin typeface="Times New Roman" pitchFamily="34" charset="0"/>
-                <a:ea typeface="Times New Roman" pitchFamily="34" charset="-122"/>
-                <a:cs typeface="Times New Roman" pitchFamily="34" charset="-120"/>
-              </a:rPr>
-              <a:t>Overall budget: </a:t>
-            </a:r>
-            <a:pPr algn="l" indent="0" marL="0">
-              <a:spcAft>
-                <a:spcPts val="800"/>
-              </a:spcAft>
-              <a:buNone/>
-            </a:pPr>
-            <a:r>
-              <a:rPr lang="en-US" sz="3200" dirty="0">
-                <a:solidFill>
-                  <a:srgbClr val="111111"/>
-                </a:solidFill>
-                <a:latin typeface="Times New Roman" pitchFamily="34" charset="0"/>
-                <a:ea typeface="Times New Roman" pitchFamily="34" charset="-122"/>
-                <a:cs typeface="Times New Roman" pitchFamily="34" charset="-120"/>
-              </a:rPr>
-              <a:t>Only about half of the solar energy reaching the top of the atmosphere is absorbed by the ground.</a:t>
-            </a:r>
-            <a:endParaRPr lang="en-US" sz="3200" dirty="0"/>
-          </a:p>
-        </p:txBody>
-      </p:sp>
       <p:pic>
         <p:nvPicPr>
-          <p:cNvPr id="5" name="Image 0" descr="/home/claude/f4/img/v2/depletion_big.png">    </p:cNvPr>
+          <p:cNvPr id="3" name="Image 0" descr="/home/claude/f4/img/minesec_sheet.png">    </p:cNvPr>
           <p:cNvPicPr>
             <a:picLocks noChangeAspect="1"/>
           </p:cNvPicPr>
@@ -15992,8 +16006,8 @@
         </p:blipFill>
         <p:spPr>
           <a:xfrm>
-            <a:off x="5349240" y="2617506"/>
-            <a:ext cx="6659575" cy="2601397"/>
+            <a:off x="0" y="658368"/>
+            <a:ext cx="5120640" cy="5833872"/>
           </a:xfrm>
           <a:prstGeom prst="rect">
             <a:avLst/>
@@ -16002,14 +16016,14 @@
       </p:pic>
       <p:sp>
         <p:nvSpPr>
-          <p:cNvPr id="6" name="Text 3"/>
+          <p:cNvPr id="4" name="Text 1"/>
           <p:cNvSpPr/>
           <p:nvPr/>
         </p:nvSpPr>
         <p:spPr>
           <a:xfrm>
-            <a:off x="5349240" y="6089904"/>
-            <a:ext cx="6659575" cy="347472"/>
+            <a:off x="5349240" y="1005840"/>
+            <a:ext cx="6522415" cy="731520"/>
           </a:xfrm>
           <a:prstGeom prst="rect">
             <a:avLst/>
@@ -16018,24 +16032,124 @@
           <a:ln/>
         </p:spPr>
         <p:txBody>
-          <a:bodyPr wrap="square" lIns="0" tIns="0" rIns="0" bIns="0" rtlCol="0" anchor="ctr"/>
+          <a:bodyPr wrap="square" lIns="0" tIns="0" rIns="0" bIns="0" rtlCol="0" anchor="ctr">
+            <a:normAutofit/>
+          </a:bodyPr>
           <a:lstStyle/>
           <a:p>
             <a:pPr algn="ctr" indent="0" marL="0">
               <a:buNone/>
             </a:pPr>
             <a:r>
-              <a:rPr lang="en-US" sz="1600" i="1" dirty="0">
-                <a:solidFill>
-                  <a:srgbClr val="555555"/>
+              <a:rPr lang="en-US" sz="3600" b="1" dirty="0">
+                <a:solidFill>
+                  <a:srgbClr val="990011"/>
                 </a:solidFill>
                 <a:latin typeface="Times New Roman" pitchFamily="34" charset="0"/>
                 <a:ea typeface="Times New Roman" pitchFamily="34" charset="-122"/>
                 <a:cs typeface="Times New Roman" pitchFamily="34" charset="-120"/>
               </a:rPr>
-              <a:t>Illustration: what happens to sunlight</a:t>
-            </a:r>
-            <a:endParaRPr lang="en-US" sz="1600" dirty="0"/>
+              <a:t>1. Source and Nature of Solar Radiation</a:t>
+            </a:r>
+            <a:endParaRPr lang="en-US" sz="3600" dirty="0"/>
+          </a:p>
+        </p:txBody>
+      </p:sp>
+      <p:sp>
+        <p:nvSpPr>
+          <p:cNvPr id="5" name="Text 2"/>
+          <p:cNvSpPr/>
+          <p:nvPr/>
+        </p:nvSpPr>
+        <p:spPr>
+          <a:xfrm>
+            <a:off x="5349240" y="1737360"/>
+            <a:ext cx="6522415" cy="457200"/>
+          </a:xfrm>
+          <a:prstGeom prst="rect">
+            <a:avLst/>
+          </a:prstGeom>
+          <a:noFill/>
+          <a:ln/>
+        </p:spPr>
+        <p:txBody>
+          <a:bodyPr wrap="square" lIns="0" tIns="0" rIns="0" bIns="0" rtlCol="0" anchor="ctr"/>
+          <a:lstStyle/>
+          <a:p>
+            <a:pPr algn="l" indent="0" marL="0">
+              <a:buNone/>
+            </a:pPr>
+            <a:r>
+              <a:rPr lang="en-US" sz="3200" b="1" dirty="0">
+                <a:solidFill>
+                  <a:srgbClr val="990011"/>
+                </a:solidFill>
+                <a:latin typeface="Times New Roman" pitchFamily="34" charset="0"/>
+                <a:ea typeface="Times New Roman" pitchFamily="34" charset="-122"/>
+                <a:cs typeface="Times New Roman" pitchFamily="34" charset="-120"/>
+              </a:rPr>
+              <a:t>B) Nature</a:t>
+            </a:r>
+            <a:endParaRPr lang="en-US" sz="3200" dirty="0"/>
+          </a:p>
+        </p:txBody>
+      </p:sp>
+      <p:sp>
+        <p:nvSpPr>
+          <p:cNvPr id="6" name="Text 3"/>
+          <p:cNvSpPr/>
+          <p:nvPr/>
+        </p:nvSpPr>
+        <p:spPr>
+          <a:xfrm>
+            <a:off x="5349240" y="2240280"/>
+            <a:ext cx="6522415" cy="4206240"/>
+          </a:xfrm>
+          <a:prstGeom prst="rect">
+            <a:avLst/>
+          </a:prstGeom>
+          <a:noFill/>
+          <a:ln/>
+        </p:spPr>
+        <p:txBody>
+          <a:bodyPr wrap="square" lIns="0" tIns="0" rIns="0" bIns="0" rtlCol="0" anchor="t"/>
+          <a:lstStyle/>
+          <a:p>
+            <a:pPr algn="l" indent="0" marL="0">
+              <a:spcAft>
+                <a:spcPts val="800"/>
+              </a:spcAft>
+              <a:buNone/>
+            </a:pPr>
+            <a:r>
+              <a:rPr lang="en-US" sz="4000" b="1" dirty="0">
+                <a:solidFill>
+                  <a:srgbClr val="111111"/>
+                </a:solidFill>
+                <a:latin typeface="Times New Roman" pitchFamily="34" charset="0"/>
+                <a:ea typeface="Times New Roman" pitchFamily="34" charset="-122"/>
+                <a:cs typeface="Times New Roman" pitchFamily="34" charset="-120"/>
+              </a:rPr>
+              <a:t>Infrared rays (about 51 %): </a:t>
+            </a:r>
+            <a:pPr algn="l" indent="0" marL="0">
+              <a:spcAft>
+                <a:spcPts val="800"/>
+              </a:spcAft>
+              <a:buNone/>
+            </a:pPr>
+            <a:r>
+              <a:rPr lang="en-US" sz="4000" dirty="0">
+                <a:solidFill>
+                  <a:srgbClr val="111111"/>
+                </a:solidFill>
+                <a:latin typeface="Times New Roman" pitchFamily="34" charset="0"/>
+                <a:ea typeface="Times New Roman" pitchFamily="34" charset="-122"/>
+                <a:cs typeface="Times New Roman" pitchFamily="34" charset="-120"/>
+              </a:rPr>
+              <a:t>They are longer, invisible waves felt as heat. They warm the surface and are partly absorbed by water vapour and carbon dioxide.</a:t>
+            </a:r>
+            <a:endParaRPr lang="en-US" sz="4000" dirty="0"/>
           </a:p>
         </p:txBody>
       </p:sp>
@@ -16186,7 +16300,7 @@
                 <a:ea typeface="Times New Roman" pitchFamily="34" charset="-122"/>
                 <a:cs typeface="Times New Roman" pitchFamily="34" charset="-120"/>
               </a:rPr>
-              <a:t>2. Depletion of Solar Radiation in the Atmosphere</a:t>
+              <a:t>2. Depletion of Solar Radiation</a:t>
             </a:r>
             <a:endParaRPr lang="en-US" sz="3600" dirty="0"/>
           </a:p>
@@ -16201,7 +16315,7 @@
         <p:spPr>
           <a:xfrm>
             <a:off x="365760" y="1783080"/>
-            <a:ext cx="4846320" cy="4617720"/>
+            <a:ext cx="6035040" cy="4617720"/>
           </a:xfrm>
           <a:prstGeom prst="rect">
             <a:avLst/>
@@ -16220,7 +16334,7 @@
               <a:buNone/>
             </a:pPr>
             <a:r>
-              <a:rPr lang="en-US" sz="3600" b="1" dirty="0">
+              <a:rPr lang="en-US" sz="2600" i="1" dirty="0">
                 <a:solidFill>
                   <a:srgbClr val="111111"/>
                 </a:solidFill>
@@ -16228,8 +16342,11 @@
                 <a:ea typeface="Times New Roman" pitchFamily="34" charset="-122"/>
                 <a:cs typeface="Times New Roman" pitchFamily="34" charset="-120"/>
               </a:rPr>
-              <a:t>Reflection: </a:t>
-            </a:r>
+              <a:t>Solar radiation is reduced as it crosses the atmosphere by the following processes:</a:t>
+            </a:r>
+            <a:endParaRPr lang="en-US" sz="2600" dirty="0"/>
+          </a:p>
+          <a:p>
             <a:pPr algn="l" indent="0" marL="0">
               <a:spcAft>
                 <a:spcPts val="800"/>
@@ -16237,7 +16354,7 @@
               <a:buNone/>
             </a:pPr>
             <a:r>
-              <a:rPr lang="en-US" sz="3600" dirty="0">
+              <a:rPr lang="en-US" sz="2600" b="1" dirty="0">
                 <a:solidFill>
                   <a:srgbClr val="111111"/>
                 </a:solidFill>
@@ -16245,9 +16362,26 @@
                 <a:ea typeface="Times New Roman" pitchFamily="34" charset="-122"/>
                 <a:cs typeface="Times New Roman" pitchFamily="34" charset="-120"/>
               </a:rPr>
-              <a:t>Clouds and bright surfaces send radiation back to space; the proportion reflected is the albedo.</a:t>
-            </a:r>
-            <a:endParaRPr lang="en-US" sz="3600" dirty="0"/>
+              <a:t>Reflection: </a:t>
+            </a:r>
+            <a:pPr algn="l" indent="0" marL="0">
+              <a:spcAft>
+                <a:spcPts val="800"/>
+              </a:spcAft>
+              <a:buNone/>
+            </a:pPr>
+            <a:r>
+              <a:rPr lang="en-US" sz="2600" dirty="0">
+                <a:solidFill>
+                  <a:srgbClr val="111111"/>
+                </a:solidFill>
+                <a:latin typeface="Times New Roman" pitchFamily="34" charset="0"/>
+                <a:ea typeface="Times New Roman" pitchFamily="34" charset="-122"/>
+                <a:cs typeface="Times New Roman" pitchFamily="34" charset="-120"/>
+              </a:rPr>
+              <a:t>Clouds, snow, ice and bright surfaces send part of the radiation back to space without changing it. The proportion reflected is the albedo: fresh snow reflects about 85 %, thick clouds up to 90 %, forests about 12 % and a tarred road less than 10 %.</a:t>
+            </a:r>
+            <a:endParaRPr lang="en-US" sz="2600" dirty="0"/>
           </a:p>
         </p:txBody>
       </p:sp>
@@ -16267,8 +16401,8 @@
         </p:blipFill>
         <p:spPr>
           <a:xfrm>
-            <a:off x="5349240" y="2617506"/>
-            <a:ext cx="6659575" cy="2601397"/>
+            <a:off x="6537960" y="2849678"/>
+            <a:ext cx="5470855" cy="2137053"/>
           </a:xfrm>
           <a:prstGeom prst="rect">
             <a:avLst/>
@@ -16283,8 +16417,8 @@
         </p:nvSpPr>
         <p:spPr>
           <a:xfrm>
-            <a:off x="5349240" y="6089904"/>
-            <a:ext cx="6659575" cy="347472"/>
+            <a:off x="6537960" y="6089904"/>
+            <a:ext cx="5470855" cy="347472"/>
           </a:xfrm>
           <a:prstGeom prst="rect">
             <a:avLst/>
@@ -16308,7 +16442,7 @@
                 <a:ea typeface="Times New Roman" pitchFamily="34" charset="-122"/>
                 <a:cs typeface="Times New Roman" pitchFamily="34" charset="-120"/>
               </a:rPr>
-              <a:t>Illustration: albedo of surfaces</a:t>
+              <a:t>Illustration: the albedo of surfaces</a:t>
             </a:r>
             <a:endParaRPr lang="en-US" sz="1600" dirty="0"/>
           </a:p>
@@ -16426,9 +16560,109 @@
           </a:p>
         </p:txBody>
       </p:sp>
+      <p:sp>
+        <p:nvSpPr>
+          <p:cNvPr id="3" name="Text 1"/>
+          <p:cNvSpPr/>
+          <p:nvPr/>
+        </p:nvSpPr>
+        <p:spPr>
+          <a:xfrm>
+            <a:off x="365760" y="1005840"/>
+            <a:ext cx="11460175" cy="731520"/>
+          </a:xfrm>
+          <a:prstGeom prst="rect">
+            <a:avLst/>
+          </a:prstGeom>
+          <a:noFill/>
+          <a:ln/>
+        </p:spPr>
+        <p:txBody>
+          <a:bodyPr wrap="square" lIns="0" tIns="0" rIns="0" bIns="0" rtlCol="0" anchor="ctr">
+            <a:normAutofit/>
+          </a:bodyPr>
+          <a:lstStyle/>
+          <a:p>
+            <a:pPr algn="ctr" indent="0" marL="0">
+              <a:buNone/>
+            </a:pPr>
+            <a:r>
+              <a:rPr lang="en-US" sz="3600" b="1" dirty="0">
+                <a:solidFill>
+                  <a:srgbClr val="990011"/>
+                </a:solidFill>
+                <a:latin typeface="Times New Roman" pitchFamily="34" charset="0"/>
+                <a:ea typeface="Times New Roman" pitchFamily="34" charset="-122"/>
+                <a:cs typeface="Times New Roman" pitchFamily="34" charset="-120"/>
+              </a:rPr>
+              <a:t>2. Depletion of Solar Radiation</a:t>
+            </a:r>
+            <a:endParaRPr lang="en-US" sz="3600" dirty="0"/>
+          </a:p>
+        </p:txBody>
+      </p:sp>
+      <p:sp>
+        <p:nvSpPr>
+          <p:cNvPr id="4" name="Text 2"/>
+          <p:cNvSpPr/>
+          <p:nvPr/>
+        </p:nvSpPr>
+        <p:spPr>
+          <a:xfrm>
+            <a:off x="365760" y="1783080"/>
+            <a:ext cx="6035040" cy="4617720"/>
+          </a:xfrm>
+          <a:prstGeom prst="rect">
+            <a:avLst/>
+          </a:prstGeom>
+          <a:noFill/>
+          <a:ln/>
+        </p:spPr>
+        <p:txBody>
+          <a:bodyPr wrap="square" lIns="0" tIns="0" rIns="0" bIns="0" rtlCol="0" anchor="t"/>
+          <a:lstStyle/>
+          <a:p>
+            <a:pPr algn="l" indent="0" marL="0">
+              <a:spcAft>
+                <a:spcPts val="800"/>
+              </a:spcAft>
+              <a:buNone/>
+            </a:pPr>
+            <a:r>
+              <a:rPr lang="en-US" sz="3400" b="1" dirty="0">
+                <a:solidFill>
+                  <a:srgbClr val="111111"/>
+                </a:solidFill>
+                <a:latin typeface="Times New Roman" pitchFamily="34" charset="0"/>
+                <a:ea typeface="Times New Roman" pitchFamily="34" charset="-122"/>
+                <a:cs typeface="Times New Roman" pitchFamily="34" charset="-120"/>
+              </a:rPr>
+              <a:t>Scattering: </a:t>
+            </a:r>
+            <a:pPr algn="l" indent="0" marL="0">
+              <a:spcAft>
+                <a:spcPts val="800"/>
+              </a:spcAft>
+              <a:buNone/>
+            </a:pPr>
+            <a:r>
+              <a:rPr lang="en-US" sz="3400" dirty="0">
+                <a:solidFill>
+                  <a:srgbClr val="111111"/>
+                </a:solidFill>
+                <a:latin typeface="Times New Roman" pitchFamily="34" charset="0"/>
+                <a:ea typeface="Times New Roman" pitchFamily="34" charset="-122"/>
+                <a:cs typeface="Times New Roman" pitchFamily="34" charset="-120"/>
+              </a:rPr>
+              <a:t>Gas molecules and tiny particles send part of the light in all directions, and blue light is scattered most, which makes the sky blue. At sunrise and sunset, light crosses more air, so the blue is lost and the sky looks red.</a:t>
+            </a:r>
+            <a:endParaRPr lang="en-US" sz="3400" dirty="0"/>
+          </a:p>
+        </p:txBody>
+      </p:sp>
       <p:pic>
         <p:nvPicPr>
-          <p:cNvPr id="3" name="Image 0" descr="/home/claude/f4/img/minesec_sheet.png">    </p:cNvPr>
+          <p:cNvPr id="5" name="Image 0" descr="/home/claude/f4/img/v2/f4_sunrise.jpg">    </p:cNvPr>
           <p:cNvPicPr>
             <a:picLocks noChangeAspect="1"/>
           </p:cNvPicPr>
@@ -16442,8 +16676,8 @@
         </p:blipFill>
         <p:spPr>
           <a:xfrm>
-            <a:off x="0" y="658368"/>
-            <a:ext cx="5120640" cy="5833872"/>
+            <a:off x="6537960" y="2400897"/>
+            <a:ext cx="5470855" cy="3034615"/>
           </a:xfrm>
           <a:prstGeom prst="rect">
             <a:avLst/>
@@ -16452,14 +16686,14 @@
       </p:pic>
       <p:sp>
         <p:nvSpPr>
-          <p:cNvPr id="4" name="Text 1"/>
+          <p:cNvPr id="6" name="Text 3"/>
           <p:cNvSpPr/>
           <p:nvPr/>
         </p:nvSpPr>
         <p:spPr>
           <a:xfrm>
-            <a:off x="5349240" y="1005840"/>
-            <a:ext cx="6522415" cy="731520"/>
+            <a:off x="6537960" y="6089904"/>
+            <a:ext cx="5470855" cy="347472"/>
           </a:xfrm>
           <a:prstGeom prst="rect">
             <a:avLst/>
@@ -16468,85 +16702,24 @@
           <a:ln/>
         </p:spPr>
         <p:txBody>
-          <a:bodyPr wrap="square" lIns="0" tIns="0" rIns="0" bIns="0" rtlCol="0" anchor="ctr">
-            <a:normAutofit/>
-          </a:bodyPr>
+          <a:bodyPr wrap="square" lIns="0" tIns="0" rIns="0" bIns="0" rtlCol="0" anchor="ctr"/>
           <a:lstStyle/>
           <a:p>
             <a:pPr algn="ctr" indent="0" marL="0">
               <a:buNone/>
             </a:pPr>
             <a:r>
-              <a:rPr lang="en-US" sz="3600" b="1" dirty="0">
-                <a:solidFill>
-                  <a:srgbClr val="990011"/>
+              <a:rPr lang="en-US" sz="1600" i="1" dirty="0">
+                <a:solidFill>
+                  <a:srgbClr val="555555"/>
                 </a:solidFill>
                 <a:latin typeface="Times New Roman" pitchFamily="34" charset="0"/>
                 <a:ea typeface="Times New Roman" pitchFamily="34" charset="-122"/>
                 <a:cs typeface="Times New Roman" pitchFamily="34" charset="-120"/>
               </a:rPr>
-              <a:t>2. Depletion of Solar Radiation in the Atmosphere</a:t>
-            </a:r>
-            <a:endParaRPr lang="en-US" sz="3600" dirty="0"/>
-          </a:p>
-        </p:txBody>
-      </p:sp>
-      <p:sp>
-        <p:nvSpPr>
-          <p:cNvPr id="5" name="Text 2"/>
-          <p:cNvSpPr/>
-          <p:nvPr/>
-        </p:nvSpPr>
-        <p:spPr>
-          <a:xfrm>
-            <a:off x="5349240" y="1783080"/>
-            <a:ext cx="6522415" cy="4663440"/>
-          </a:xfrm>
-          <a:prstGeom prst="rect">
-            <a:avLst/>
-          </a:prstGeom>
-          <a:noFill/>
-          <a:ln/>
-        </p:spPr>
-        <p:txBody>
-          <a:bodyPr wrap="square" lIns="0" tIns="0" rIns="0" bIns="0" rtlCol="0" anchor="t"/>
-          <a:lstStyle/>
-          <a:p>
-            <a:pPr algn="l" indent="0" marL="0">
-              <a:spcAft>
-                <a:spcPts val="800"/>
-              </a:spcAft>
-              <a:buNone/>
-            </a:pPr>
-            <a:r>
-              <a:rPr lang="en-US" sz="4000" b="1" dirty="0">
-                <a:solidFill>
-                  <a:srgbClr val="111111"/>
-                </a:solidFill>
-                <a:latin typeface="Times New Roman" pitchFamily="34" charset="0"/>
-                <a:ea typeface="Times New Roman" pitchFamily="34" charset="-122"/>
-                <a:cs typeface="Times New Roman" pitchFamily="34" charset="-120"/>
-              </a:rPr>
-              <a:t>Examples of albedo: </a:t>
-            </a:r>
-            <a:pPr algn="l" indent="0" marL="0">
-              <a:spcAft>
-                <a:spcPts val="800"/>
-              </a:spcAft>
-              <a:buNone/>
-            </a:pPr>
-            <a:r>
-              <a:rPr lang="en-US" sz="4000" dirty="0">
-                <a:solidFill>
-                  <a:srgbClr val="111111"/>
-                </a:solidFill>
-                <a:latin typeface="Times New Roman" pitchFamily="34" charset="0"/>
-                <a:ea typeface="Times New Roman" pitchFamily="34" charset="-122"/>
-                <a:cs typeface="Times New Roman" pitchFamily="34" charset="-120"/>
-              </a:rPr>
-              <a:t>Fresh snow reflects about 85 %, thick clouds up to 90 %, forests about 12 % and a tarred road less than 10 %.</a:t>
-            </a:r>
-            <a:endParaRPr lang="en-US" sz="4000" dirty="0"/>
+              <a:t>Illustration: a red sunrise</a:t>
+            </a:r>
+            <a:endParaRPr lang="en-US" sz="1600" dirty="0"/>
           </a:p>
         </p:txBody>
       </p:sp>
@@ -16662,109 +16835,9 @@
           </a:p>
         </p:txBody>
       </p:sp>
-      <p:sp>
-        <p:nvSpPr>
-          <p:cNvPr id="3" name="Text 1"/>
-          <p:cNvSpPr/>
-          <p:nvPr/>
-        </p:nvSpPr>
-        <p:spPr>
-          <a:xfrm>
-            <a:off x="365760" y="1005840"/>
-            <a:ext cx="11460175" cy="731520"/>
-          </a:xfrm>
-          <a:prstGeom prst="rect">
-            <a:avLst/>
-          </a:prstGeom>
-          <a:noFill/>
-          <a:ln/>
-        </p:spPr>
-        <p:txBody>
-          <a:bodyPr wrap="square" lIns="0" tIns="0" rIns="0" bIns="0" rtlCol="0" anchor="ctr">
-            <a:normAutofit/>
-          </a:bodyPr>
-          <a:lstStyle/>
-          <a:p>
-            <a:pPr algn="ctr" indent="0" marL="0">
-              <a:buNone/>
-            </a:pPr>
-            <a:r>
-              <a:rPr lang="en-US" sz="3600" b="1" dirty="0">
-                <a:solidFill>
-                  <a:srgbClr val="990011"/>
-                </a:solidFill>
-                <a:latin typeface="Times New Roman" pitchFamily="34" charset="0"/>
-                <a:ea typeface="Times New Roman" pitchFamily="34" charset="-122"/>
-                <a:cs typeface="Times New Roman" pitchFamily="34" charset="-120"/>
-              </a:rPr>
-              <a:t>2. Depletion of Solar Radiation in the Atmosphere</a:t>
-            </a:r>
-            <a:endParaRPr lang="en-US" sz="3600" dirty="0"/>
-          </a:p>
-        </p:txBody>
-      </p:sp>
-      <p:sp>
-        <p:nvSpPr>
-          <p:cNvPr id="4" name="Text 2"/>
-          <p:cNvSpPr/>
-          <p:nvPr/>
-        </p:nvSpPr>
-        <p:spPr>
-          <a:xfrm>
-            <a:off x="365760" y="1783080"/>
-            <a:ext cx="4846320" cy="4617720"/>
-          </a:xfrm>
-          <a:prstGeom prst="rect">
-            <a:avLst/>
-          </a:prstGeom>
-          <a:noFill/>
-          <a:ln/>
-        </p:spPr>
-        <p:txBody>
-          <a:bodyPr wrap="square" lIns="0" tIns="0" rIns="0" bIns="0" rtlCol="0" anchor="t"/>
-          <a:lstStyle/>
-          <a:p>
-            <a:pPr algn="l" indent="0" marL="0">
-              <a:spcAft>
-                <a:spcPts val="800"/>
-              </a:spcAft>
-              <a:buNone/>
-            </a:pPr>
-            <a:r>
-              <a:rPr lang="en-US" sz="3600" b="1" dirty="0">
-                <a:solidFill>
-                  <a:srgbClr val="111111"/>
-                </a:solidFill>
-                <a:latin typeface="Times New Roman" pitchFamily="34" charset="0"/>
-                <a:ea typeface="Times New Roman" pitchFamily="34" charset="-122"/>
-                <a:cs typeface="Times New Roman" pitchFamily="34" charset="-120"/>
-              </a:rPr>
-              <a:t>Scattering: </a:t>
-            </a:r>
-            <a:pPr algn="l" indent="0" marL="0">
-              <a:spcAft>
-                <a:spcPts val="800"/>
-              </a:spcAft>
-              <a:buNone/>
-            </a:pPr>
-            <a:r>
-              <a:rPr lang="en-US" sz="3600" dirty="0">
-                <a:solidFill>
-                  <a:srgbClr val="111111"/>
-                </a:solidFill>
-                <a:latin typeface="Times New Roman" pitchFamily="34" charset="0"/>
-                <a:ea typeface="Times New Roman" pitchFamily="34" charset="-122"/>
-                <a:cs typeface="Times New Roman" pitchFamily="34" charset="-120"/>
-              </a:rPr>
-              <a:t>Molecules scatter blue light, so the sky is blue; at sunrise and sunset, light crosses more air and looks red.</a:t>
-            </a:r>
-            <a:endParaRPr lang="en-US" sz="3600" dirty="0"/>
-          </a:p>
-        </p:txBody>
-      </p:sp>
       <p:pic>
         <p:nvPicPr>
-          <p:cNvPr id="5" name="Image 0" descr="/home/claude/f4/img/v2/f4_sunrise.jpg">    </p:cNvPr>
+          <p:cNvPr id="3" name="Image 0" descr="/home/claude/f4/img/minesec_sheet.png">    </p:cNvPr>
           <p:cNvPicPr>
             <a:picLocks noChangeAspect="1"/>
           </p:cNvPicPr>
@@ -16778,8 +16851,8 @@
         </p:blipFill>
         <p:spPr>
           <a:xfrm>
-            <a:off x="5349240" y="2071212"/>
-            <a:ext cx="6659575" cy="3693983"/>
+            <a:off x="0" y="658368"/>
+            <a:ext cx="5120640" cy="5833872"/>
           </a:xfrm>
           <a:prstGeom prst="rect">
             <a:avLst/>
@@ -16788,14 +16861,14 @@
       </p:pic>
       <p:sp>
         <p:nvSpPr>
-          <p:cNvPr id="6" name="Text 3"/>
+          <p:cNvPr id="4" name="Text 1"/>
           <p:cNvSpPr/>
           <p:nvPr/>
         </p:nvSpPr>
         <p:spPr>
           <a:xfrm>
-            <a:off x="5349240" y="6089904"/>
-            <a:ext cx="6659575" cy="347472"/>
+            <a:off x="5349240" y="1005840"/>
+            <a:ext cx="6522415" cy="731520"/>
           </a:xfrm>
           <a:prstGeom prst="rect">
             <a:avLst/>
@@ -16804,24 +16877,85 @@
           <a:ln/>
         </p:spPr>
         <p:txBody>
-          <a:bodyPr wrap="square" lIns="0" tIns="0" rIns="0" bIns="0" rtlCol="0" anchor="ctr"/>
+          <a:bodyPr wrap="square" lIns="0" tIns="0" rIns="0" bIns="0" rtlCol="0" anchor="ctr">
+            <a:normAutofit/>
+          </a:bodyPr>
           <a:lstStyle/>
           <a:p>
             <a:pPr algn="ctr" indent="0" marL="0">
               <a:buNone/>
             </a:pPr>
             <a:r>
-              <a:rPr lang="en-US" sz="1600" i="1" dirty="0">
-                <a:solidFill>
-                  <a:srgbClr val="555555"/>
+              <a:rPr lang="en-US" sz="3600" b="1" dirty="0">
+                <a:solidFill>
+                  <a:srgbClr val="990011"/>
                 </a:solidFill>
                 <a:latin typeface="Times New Roman" pitchFamily="34" charset="0"/>
                 <a:ea typeface="Times New Roman" pitchFamily="34" charset="-122"/>
                 <a:cs typeface="Times New Roman" pitchFamily="34" charset="-120"/>
               </a:rPr>
-              <a:t>Illustration: a red sunrise</a:t>
-            </a:r>
-            <a:endParaRPr lang="en-US" sz="1600" dirty="0"/>
+              <a:t>2. Depletion of Solar Radiation</a:t>
+            </a:r>
+            <a:endParaRPr lang="en-US" sz="3600" dirty="0"/>
+          </a:p>
+        </p:txBody>
+      </p:sp>
+      <p:sp>
+        <p:nvSpPr>
+          <p:cNvPr id="5" name="Text 2"/>
+          <p:cNvSpPr/>
+          <p:nvPr/>
+        </p:nvSpPr>
+        <p:spPr>
+          <a:xfrm>
+            <a:off x="5349240" y="1783080"/>
+            <a:ext cx="6522415" cy="4663440"/>
+          </a:xfrm>
+          <a:prstGeom prst="rect">
+            <a:avLst/>
+          </a:prstGeom>
+          <a:noFill/>
+          <a:ln/>
+        </p:spPr>
+        <p:txBody>
+          <a:bodyPr wrap="square" lIns="0" tIns="0" rIns="0" bIns="0" rtlCol="0" anchor="t"/>
+          <a:lstStyle/>
+          <a:p>
+            <a:pPr algn="l" indent="0" marL="0">
+              <a:spcAft>
+                <a:spcPts val="800"/>
+              </a:spcAft>
+              <a:buNone/>
+            </a:pPr>
+            <a:r>
+              <a:rPr lang="en-US" sz="4000" b="1" dirty="0">
+                <a:solidFill>
+                  <a:srgbClr val="111111"/>
+                </a:solidFill>
+                <a:latin typeface="Times New Roman" pitchFamily="34" charset="0"/>
+                <a:ea typeface="Times New Roman" pitchFamily="34" charset="-122"/>
+                <a:cs typeface="Times New Roman" pitchFamily="34" charset="-120"/>
+              </a:rPr>
+              <a:t>Absorption: </a:t>
+            </a:r>
+            <a:pPr algn="l" indent="0" marL="0">
+              <a:spcAft>
+                <a:spcPts val="800"/>
+              </a:spcAft>
+              <a:buNone/>
+            </a:pPr>
+            <a:r>
+              <a:rPr lang="en-US" sz="4000" dirty="0">
+                <a:solidFill>
+                  <a:srgbClr val="111111"/>
+                </a:solidFill>
+                <a:latin typeface="Times New Roman" pitchFamily="34" charset="0"/>
+                <a:ea typeface="Times New Roman" pitchFamily="34" charset="-122"/>
+                <a:cs typeface="Times New Roman" pitchFamily="34" charset="-120"/>
+              </a:rPr>
+              <a:t>Ozone absorbs ultraviolet rays, while water vapour, carbon dioxide and dust absorb infrared rays. The absorbed energy is turned into heat that warms the atmosphere.</a:t>
+            </a:r>
+            <a:endParaRPr lang="en-US" sz="4000" dirty="0"/>
           </a:p>
         </p:txBody>
       </p:sp>
@@ -16937,9 +17071,109 @@
           </a:p>
         </p:txBody>
       </p:sp>
+      <p:sp>
+        <p:nvSpPr>
+          <p:cNvPr id="3" name="Text 1"/>
+          <p:cNvSpPr/>
+          <p:nvPr/>
+        </p:nvSpPr>
+        <p:spPr>
+          <a:xfrm>
+            <a:off x="365760" y="1005840"/>
+            <a:ext cx="11460175" cy="731520"/>
+          </a:xfrm>
+          <a:prstGeom prst="rect">
+            <a:avLst/>
+          </a:prstGeom>
+          <a:noFill/>
+          <a:ln/>
+        </p:spPr>
+        <p:txBody>
+          <a:bodyPr wrap="square" lIns="0" tIns="0" rIns="0" bIns="0" rtlCol="0" anchor="ctr">
+            <a:normAutofit/>
+          </a:bodyPr>
+          <a:lstStyle/>
+          <a:p>
+            <a:pPr algn="ctr" indent="0" marL="0">
+              <a:buNone/>
+            </a:pPr>
+            <a:r>
+              <a:rPr lang="en-US" sz="3600" b="1" dirty="0">
+                <a:solidFill>
+                  <a:srgbClr val="990011"/>
+                </a:solidFill>
+                <a:latin typeface="Times New Roman" pitchFamily="34" charset="0"/>
+                <a:ea typeface="Times New Roman" pitchFamily="34" charset="-122"/>
+                <a:cs typeface="Times New Roman" pitchFamily="34" charset="-120"/>
+              </a:rPr>
+              <a:t>2. Depletion of Solar Radiation</a:t>
+            </a:r>
+            <a:endParaRPr lang="en-US" sz="3600" dirty="0"/>
+          </a:p>
+        </p:txBody>
+      </p:sp>
+      <p:sp>
+        <p:nvSpPr>
+          <p:cNvPr id="4" name="Text 2"/>
+          <p:cNvSpPr/>
+          <p:nvPr/>
+        </p:nvSpPr>
+        <p:spPr>
+          <a:xfrm>
+            <a:off x="365760" y="1783080"/>
+            <a:ext cx="6035040" cy="4617720"/>
+          </a:xfrm>
+          <a:prstGeom prst="rect">
+            <a:avLst/>
+          </a:prstGeom>
+          <a:noFill/>
+          <a:ln/>
+        </p:spPr>
+        <p:txBody>
+          <a:bodyPr wrap="square" lIns="0" tIns="0" rIns="0" bIns="0" rtlCol="0" anchor="t"/>
+          <a:lstStyle/>
+          <a:p>
+            <a:pPr algn="l" indent="0" marL="0">
+              <a:spcAft>
+                <a:spcPts val="800"/>
+              </a:spcAft>
+              <a:buNone/>
+            </a:pPr>
+            <a:r>
+              <a:rPr lang="en-US" sz="3200" b="1" dirty="0">
+                <a:solidFill>
+                  <a:srgbClr val="111111"/>
+                </a:solidFill>
+                <a:latin typeface="Times New Roman" pitchFamily="34" charset="0"/>
+                <a:ea typeface="Times New Roman" pitchFamily="34" charset="-122"/>
+                <a:cs typeface="Times New Roman" pitchFamily="34" charset="-120"/>
+              </a:rPr>
+              <a:t>Energy reaching the surface: </a:t>
+            </a:r>
+            <a:pPr algn="l" indent="0" marL="0">
+              <a:spcAft>
+                <a:spcPts val="800"/>
+              </a:spcAft>
+              <a:buNone/>
+            </a:pPr>
+            <a:r>
+              <a:rPr lang="en-US" sz="3200" dirty="0">
+                <a:solidFill>
+                  <a:srgbClr val="111111"/>
+                </a:solidFill>
+                <a:latin typeface="Times New Roman" pitchFamily="34" charset="0"/>
+                <a:ea typeface="Times New Roman" pitchFamily="34" charset="-122"/>
+                <a:cs typeface="Times New Roman" pitchFamily="34" charset="-120"/>
+              </a:rPr>
+              <a:t>Because of these three processes, only about half of the solar energy reaching the top of the atmosphere is absorbed by the ground. About 30 % is reflected to space and about 20 % is absorbed by the air and clouds.</a:t>
+            </a:r>
+            <a:endParaRPr lang="en-US" sz="3200" dirty="0"/>
+          </a:p>
+        </p:txBody>
+      </p:sp>
       <p:pic>
         <p:nvPicPr>
-          <p:cNvPr id="3" name="Image 0" descr="/home/claude/f4/img/minesec_sheet.png">    </p:cNvPr>
+          <p:cNvPr id="5" name="Image 0" descr="/home/claude/f4/img/v2/depletion_big.png">    </p:cNvPr>
           <p:cNvPicPr>
             <a:picLocks noChangeAspect="1"/>
           </p:cNvPicPr>
@@ -16953,8 +17187,8 @@
         </p:blipFill>
         <p:spPr>
           <a:xfrm>
-            <a:off x="0" y="658368"/>
-            <a:ext cx="5120640" cy="5833872"/>
+            <a:off x="6537960" y="2849678"/>
+            <a:ext cx="5470855" cy="2137053"/>
           </a:xfrm>
           <a:prstGeom prst="rect">
             <a:avLst/>
@@ -16963,14 +17197,14 @@
       </p:pic>
       <p:sp>
         <p:nvSpPr>
-          <p:cNvPr id="4" name="Text 1"/>
+          <p:cNvPr id="6" name="Text 3"/>
           <p:cNvSpPr/>
           <p:nvPr/>
         </p:nvSpPr>
         <p:spPr>
           <a:xfrm>
-            <a:off x="5349240" y="1005840"/>
-            <a:ext cx="6522415" cy="731520"/>
+            <a:off x="6537960" y="6089904"/>
+            <a:ext cx="5470855" cy="347472"/>
           </a:xfrm>
           <a:prstGeom prst="rect">
             <a:avLst/>
@@ -16979,85 +17213,24 @@
           <a:ln/>
         </p:spPr>
         <p:txBody>
-          <a:bodyPr wrap="square" lIns="0" tIns="0" rIns="0" bIns="0" rtlCol="0" anchor="ctr">
-            <a:normAutofit/>
-          </a:bodyPr>
+          <a:bodyPr wrap="square" lIns="0" tIns="0" rIns="0" bIns="0" rtlCol="0" anchor="ctr"/>
           <a:lstStyle/>
           <a:p>
             <a:pPr algn="ctr" indent="0" marL="0">
               <a:buNone/>
             </a:pPr>
             <a:r>
-              <a:rPr lang="en-US" sz="3600" b="1" dirty="0">
-                <a:solidFill>
-                  <a:srgbClr val="990011"/>
+              <a:rPr lang="en-US" sz="1600" i="1" dirty="0">
+                <a:solidFill>
+                  <a:srgbClr val="555555"/>
                 </a:solidFill>
                 <a:latin typeface="Times New Roman" pitchFamily="34" charset="0"/>
                 <a:ea typeface="Times New Roman" pitchFamily="34" charset="-122"/>
                 <a:cs typeface="Times New Roman" pitchFamily="34" charset="-120"/>
               </a:rPr>
-              <a:t>2. Depletion of Solar Radiation in the Atmosphere</a:t>
-            </a:r>
-            <a:endParaRPr lang="en-US" sz="3600" dirty="0"/>
-          </a:p>
-        </p:txBody>
-      </p:sp>
-      <p:sp>
-        <p:nvSpPr>
-          <p:cNvPr id="5" name="Text 2"/>
-          <p:cNvSpPr/>
-          <p:nvPr/>
-        </p:nvSpPr>
-        <p:spPr>
-          <a:xfrm>
-            <a:off x="5349240" y="1783080"/>
-            <a:ext cx="6522415" cy="4663440"/>
-          </a:xfrm>
-          <a:prstGeom prst="rect">
-            <a:avLst/>
-          </a:prstGeom>
-          <a:noFill/>
-          <a:ln/>
-        </p:spPr>
-        <p:txBody>
-          <a:bodyPr wrap="square" lIns="0" tIns="0" rIns="0" bIns="0" rtlCol="0" anchor="t"/>
-          <a:lstStyle/>
-          <a:p>
-            <a:pPr algn="l" indent="0" marL="0">
-              <a:spcAft>
-                <a:spcPts val="800"/>
-              </a:spcAft>
-              <a:buNone/>
-            </a:pPr>
-            <a:r>
-              <a:rPr lang="en-US" sz="4000" b="1" dirty="0">
-                <a:solidFill>
-                  <a:srgbClr val="111111"/>
-                </a:solidFill>
-                <a:latin typeface="Times New Roman" pitchFamily="34" charset="0"/>
-                <a:ea typeface="Times New Roman" pitchFamily="34" charset="-122"/>
-                <a:cs typeface="Times New Roman" pitchFamily="34" charset="-120"/>
-              </a:rPr>
-              <a:t>Absorption: </a:t>
-            </a:r>
-            <a:pPr algn="l" indent="0" marL="0">
-              <a:spcAft>
-                <a:spcPts val="800"/>
-              </a:spcAft>
-              <a:buNone/>
-            </a:pPr>
-            <a:r>
-              <a:rPr lang="en-US" sz="4000" dirty="0">
-                <a:solidFill>
-                  <a:srgbClr val="111111"/>
-                </a:solidFill>
-                <a:latin typeface="Times New Roman" pitchFamily="34" charset="0"/>
-                <a:ea typeface="Times New Roman" pitchFamily="34" charset="-122"/>
-                <a:cs typeface="Times New Roman" pitchFamily="34" charset="-120"/>
-              </a:rPr>
-              <a:t>Ozone absorbs ultraviolet rays, while water vapour and carbon dioxide absorb infrared heat.</a:t>
-            </a:r>
-            <a:endParaRPr lang="en-US" sz="4000" dirty="0"/>
+              <a:t>Illustration: the depletion of solar radiation</a:t>
+            </a:r>
+            <a:endParaRPr lang="en-US" sz="1600" dirty="0"/>
           </a:p>
         </p:txBody>
       </p:sp>
@@ -21042,7 +21215,7 @@
                           <a:ea typeface="Calibri" pitchFamily="34" charset="-122"/>
                           <a:cs typeface="Calibri" pitchFamily="34" charset="-120"/>
                         </a:rPr>
-                        <a:t>DEFINITIONS; Source and Nature of Solar Radiation; Depletion of Solar Radiation in the Atmosphere.</a:t>
+                        <a:t>DEFINITIONS; Source; Nature; Depletion of Solar Radiation.</a:t>
                       </a:r>
                       <a:endParaRPr lang="en-US" sz="1600" dirty="0">
                         <a:latin typeface="Calibri" charset="0"/>

</xml_diff>